<commit_message>
docs: sync KISS Sorcar lecture slides with latest LaTeX source
User prompt:
can you update the slides at PWD/papers/kisssorcar/KISS_Sorcar_Lecture.pptx based on the latest PWD/papers/kisssorcar/kiss_sorcar.tex ?
</commit_message>
<xml_diff>
--- a/papers/kisssorcar/KISS_Sorcar_Lecture.pptx
+++ b/papers/kisssorcar/KISS_Sorcar_Lecture.pptx
@@ -4123,7 +4123,7 @@
               </a:defRPr>
             </a:pPr>
             <a:r>
-              <a:t>702 lines</a:t>
+              <a:t>741 lines</a:t>
             </a:r>
           </a:p>
         </p:txBody>
@@ -4219,7 +4219,7 @@
               </a:defRPr>
             </a:pPr>
             <a:r>
-              <a:t>125 lines</a:t>
+              <a:t>317 lines</a:t>
             </a:r>
           </a:p>
         </p:txBody>
@@ -4315,7 +4315,7 @@
               </a:defRPr>
             </a:pPr>
             <a:r>
-              <a:t>322 lines</a:t>
+              <a:t>744 lines</a:t>
             </a:r>
           </a:p>
         </p:txBody>
@@ -4411,7 +4411,7 @@
               </a:defRPr>
             </a:pPr>
             <a:r>
-              <a:t>328 lines</a:t>
+              <a:t>433 lines</a:t>
             </a:r>
           </a:p>
         </p:txBody>
@@ -4507,7 +4507,7 @@
               </a:defRPr>
             </a:pPr>
             <a:r>
-              <a:t>415 lines</a:t>
+              <a:t>428 lines</a:t>
             </a:r>
           </a:p>
         </p:txBody>
@@ -4542,7 +4542,7 @@
               </a:defRPr>
             </a:pPr>
             <a:r>
-              <a:t>Total: ~1,900 lines of Python  •  Strict inheritance chain  •  Each layer delegates upward</a:t>
+              <a:t>Total: ~2,700 lines of Python  •  Strict inheritance chain  •  Each layer delegates upward</a:t>
             </a:r>
           </a:p>
         </p:txBody>
@@ -10876,7 +10876,7 @@
               </a:defRPr>
             </a:pPr>
             <a:r>
-              <a:t>Self-Improvement Loop</a:t>
+              <a:t>Real-Time Data</a:t>
             </a:r>
           </a:p>
         </p:txBody>
@@ -11034,7 +11034,7 @@
               </a:defRPr>
             </a:pPr>
             <a:r>
-              <a:t>Web Research + Real-Time Data</a:t>
+              <a:t>Web Research</a:t>
             </a:r>
           </a:p>
         </p:txBody>
@@ -13316,7 +13316,7 @@
               </a:defRPr>
             </a:pPr>
             <a:r>
-              <a:t>Mandatory first reads: SORCAR.md, then USER_DEFS.md.</a:t>
+              <a:t>Mandatory first read: SORCAR.md — follow its instructions with highest priority.</a:t>
             </a:r>
           </a:p>
         </p:txBody>
@@ -17218,7 +17218,7 @@
               </a:defRPr>
             </a:pPr>
             <a:r>
-              <a:t>Self-Improvement Loop — Cross-Session Learning</a:t>
+              <a:t>Prompt Evolution — Removing the Self-Improvement Loop</a:t>
             </a:r>
           </a:p>
         </p:txBody>
@@ -17272,7 +17272,7 @@
               </a:defRPr>
             </a:pPr>
             <a:r>
-              <a:t>Mandatory first reads:</a:t>
+              <a:t>Earlier SYSTEM.md:</a:t>
             </a:r>
           </a:p>
           <a:p>
@@ -17284,7 +17284,7 @@
               </a:defRPr>
             </a:pPr>
             <a:r>
-              <a:t>SORCAR.md, USER_DEFS.md</a:t>
+              <a:t>agent updated USER_PREFS.md each task</a:t>
             </a:r>
           </a:p>
         </p:txBody>
@@ -17338,7 +17338,7 @@
               </a:defRPr>
             </a:pPr>
             <a:r>
-              <a:t>Execute task with</a:t>
+              <a:t>91-task production audit:</a:t>
             </a:r>
           </a:p>
           <a:p>
@@ -17350,7 +17350,7 @@
               </a:defRPr>
             </a:pPr>
             <a:r>
-              <a:t>accumulated knowledge</a:t>
+              <a:t>0% compliance — never updated</a:t>
             </a:r>
           </a:p>
         </p:txBody>
@@ -17404,7 +17404,7 @@
               </a:defRPr>
             </a:pPr>
             <a:r>
-              <a:t>Before finish: update</a:t>
+              <a:t>CRITICAL markers:</a:t>
             </a:r>
           </a:p>
           <a:p>
@@ -17416,7 +17416,7 @@
               </a:defRPr>
             </a:pPr>
             <a:r>
-              <a:t>USER_PREFS.md</a:t>
+              <a:t>helped tests, not production</a:t>
             </a:r>
           </a:p>
         </p:txBody>
@@ -17470,7 +17470,7 @@
               </a:defRPr>
             </a:pPr>
             <a:r>
-              <a:t>Resolve conflicts</a:t>
+              <a:t>Removed entirely:</a:t>
             </a:r>
           </a:p>
           <a:p>
@@ -17482,7 +17482,7 @@
               </a:defRPr>
             </a:pPr>
             <a:r>
-              <a:t>with existing prefs</a:t>
+              <a:t>USER_PREFS.md deleted</a:t>
             </a:r>
           </a:p>
         </p:txBody>
@@ -17517,7 +17517,7 @@
               </a:defRPr>
             </a:pPr>
             <a:r>
-              <a:t>• No code snippets in preferences — they become stale as codebase evolves</a:t>
+              <a:t>• A second audit of 91 production tasks found the in-prompt loop had 0% compliance</a:t>
             </a:r>
           </a:p>
         </p:txBody>
@@ -17552,7 +17552,7 @@
               </a:defRPr>
             </a:pPr>
             <a:r>
-              <a:t>• Actively resolve contradictions when updating (e.g. camelCase vs snake_case)</a:t>
+              <a:t>• Relocating it to a post-task sub-agent accumulated noise faster than useful invariants</a:t>
             </a:r>
           </a:p>
         </p:txBody>
@@ -17587,7 +17587,7 @@
               </a:defRPr>
             </a:pPr>
             <a:r>
-              <a:t>• Information NOT stored in databases or multiple folders — stale data is impossible to clean up</a:t>
+              <a:t>• Project knowledge is better captured in the per-repository SORCAR.md the user controls</a:t>
             </a:r>
           </a:p>
         </p:txBody>
@@ -17622,7 +17622,7 @@
               </a:defRPr>
             </a:pPr>
             <a:r>
-              <a:t>• Keep USER_PREFS.md small — it loads into every future task’s context</a:t>
+              <a:t>• Removing it shrinks the prompt and concentrates knowledge in one human-curated place</a:t>
             </a:r>
           </a:p>
         </p:txBody>
@@ -19946,7 +19946,7 @@
               </a:defRPr>
             </a:pPr>
             <a:r>
-              <a:t>• KISS Sorcar: no fine-tuning, no benchmark-specific optimizations, ~1,900 lines of Python</a:t>
+              <a:t>• KISS Sorcar: no fine-tuning, no benchmark-specific optimizations, ~2,700 lines of Python</a:t>
             </a:r>
           </a:p>
         </p:txBody>
@@ -20391,7 +20391,7 @@
               </a:defRPr>
             </a:pPr>
             <a:r>
-              <a:t>Cross-Session Self-Improvement</a:t>
+              <a:t>Git Worktree Isolation &amp; One-Click Merge</a:t>
             </a:r>
           </a:p>
           <a:p>
@@ -20406,7 +20406,7 @@
               </a:defRPr>
             </a:pPr>
             <a:r>
-              <a:t>USER_PREFS.md is read at start and updated at end of each task.</a:t>
+              <a:t>Every task runs on its own git branch in a separate worktree.</a:t>
             </a:r>
           </a:p>
           <a:p>
@@ -20421,7 +20421,7 @@
               </a:defRPr>
             </a:pPr>
             <a:r>
-              <a:t>Agent accumulates project knowledge over time — no manual config needed.</a:t>
+              <a:t>After the task: one-click “Commit and Merge” or “Discard.”</a:t>
             </a:r>
           </a:p>
           <a:p>
@@ -20436,7 +20436,7 @@
               </a:defRPr>
             </a:pPr>
             <a:r>
-              <a:t>Conflicts are actively resolved. No other IDE assistant does this.</a:t>
+              <a:t>User's working tree stays untouched; review happens on the branch.</a:t>
             </a:r>
           </a:p>
         </p:txBody>
@@ -23182,7 +23182,7 @@
               </a:defRPr>
             </a:pPr>
             <a:r>
-              <a:t>• KISS Sorcar: no fine-tuning, no benchmark-specific optimizations, ~1,900 lines of Python</a:t>
+              <a:t>• KISS Sorcar: no fine-tuning, no benchmark-specific optimizations, ~2,700 lines of Python</a:t>
             </a:r>
           </a:p>
         </p:txBody>
@@ -26811,11 +26811,7 @@
             </a:pPr>
             <a:r>
               <a:rPr lang="en-US" dirty="0"/>
-              <a:t>		</a:t>
-            </a:r>
-            <a:r>
-              <a:rPr dirty="0"/>
-              <a:t>~1,900 lines of Python beats systems with fine-tuning and RL</a:t>
+              <a:t>		~2,700 lines of Python beats systems with fine-tuning and RL</a:t>
             </a:r>
           </a:p>
         </p:txBody>
@@ -29767,7 +29763,7 @@
                   <a:srgbClr val="1B2A4A"/>
                 </a:solidFill>
               </a:rPr>
-              <a:t>Cross-Session Learning</a:t>
+              <a:t>Project Overrides</a:t>
             </a:r>
           </a:p>
         </p:txBody>
@@ -29801,7 +29797,7 @@
                   <a:srgbClr val="6B7280"/>
                 </a:solidFill>
               </a:rPr>
-              <a:t>Learns preferences and project invariants via USER_PREFS.md. Gets better over time.</a:t>
+              <a:t>Per-repository SORCAR.md customizes the agent — project knowledge in one human-curated place.</a:t>
             </a:r>
           </a:p>
         </p:txBody>
@@ -31297,7 +31293,7 @@
               </a:defRPr>
             </a:pPr>
             <a:r>
-              <a:t>KISS Agent Framework: ~1,900 lines of Python</a:t>
+              <a:t>KISS Agent Framework: ~2,700 lines of Python</a:t>
             </a:r>
           </a:p>
         </p:txBody>

</xml_diff>

<commit_message>
docs: update KISS Sorcar lecture slides to match latest source material
User prompt:
can you update the slides at PWD/papers/kisssorcar/KISS_Sorcar_Lecture.pptx based on the latest PWD/papers/kisssorcar/kiss_sorcar.tex ?
</commit_message>
<xml_diff>
--- a/papers/kisssorcar/KISS_Sorcar_Lecture.pptx
+++ b/papers/kisssorcar/KISS_Sorcar_Lecture.pptx
@@ -7441,7 +7441,7 @@
             </a:pPr>
             <a:r>
               <a:rPr dirty="0"/>
-              <a:t>  progress, step back and rethink the strategy.</a:t>
+              <a:t>  progress, step back and rethink the strategy from scratch.</a:t>
             </a:r>
           </a:p>
         </p:txBody>
@@ -7642,7 +7642,7 @@
             </a:pPr>
             <a:r>
               <a:rPr dirty="0"/>
-              <a:t>- Read the trajectory file and analyze it.</a:t>
+              <a:t>- Read the trajectory file and analyze it.  The trajectory file could be large.</a:t>
             </a:r>
           </a:p>
           <a:p>
@@ -17019,6 +17019,240 @@
             </a:pPr>
             <a:r>
               <a:t>Widen race window to make bugs deterministic in tests</a:t>
+            </a:r>
+          </a:p>
+        </p:txBody>
+      </p:sp>
+      <p:sp>
+        <p:nvSpPr>
+          <p:cNvPr id="27" name="gen_oval_27"/>
+          <p:cNvSpPr/>
+          <p:nvPr/>
+        </p:nvSpPr>
+        <p:spPr>
+          <a:xfrm>
+            <a:off x="731520" y="5486400"/>
+            <a:ext cx="164592" cy="164592"/>
+          </a:xfrm>
+          <a:prstGeom prst="ellipse">
+            <a:avLst/>
+          </a:prstGeom>
+          <a:solidFill>
+            <a:srgbClr val="7C3AED"/>
+          </a:solidFill>
+          <a:ln>
+            <a:noFill/>
+          </a:ln>
+        </p:spPr>
+        <p:style>
+          <a:lnRef idx="1">
+            <a:schemeClr val="accent1"/>
+          </a:lnRef>
+          <a:fillRef idx="3">
+            <a:schemeClr val="accent1"/>
+          </a:fillRef>
+          <a:effectRef idx="2">
+            <a:schemeClr val="accent1"/>
+          </a:effectRef>
+          <a:fontRef idx="minor">
+            <a:schemeClr val="lt1"/>
+          </a:fontRef>
+        </p:style>
+        <p:txBody>
+          <a:bodyPr rtlCol="0" anchor="ctr"/>
+          <a:lstStyle/>
+          <a:p>
+            <a:pPr algn="ctr"/>
+            <a:endParaRPr/>
+          </a:p>
+        </p:txBody>
+      </p:sp>
+      <p:sp>
+        <p:nvSpPr>
+          <p:cNvPr id="28" name="gen_title_28"/>
+          <p:cNvSpPr txBox="1"/>
+          <p:nvPr/>
+        </p:nvSpPr>
+        <p:spPr>
+          <a:xfrm>
+            <a:off x="1097280" y="5431536"/>
+            <a:ext cx="3840480" cy="502920"/>
+          </a:xfrm>
+          <a:prstGeom prst="rect">
+            <a:avLst/>
+          </a:prstGeom>
+          <a:noFill/>
+        </p:spPr>
+        <p:txBody>
+          <a:bodyPr wrap="square">
+            <a:spAutoFit/>
+          </a:bodyPr>
+          <a:lstStyle/>
+          <a:p>
+            <a:pPr>
+              <a:defRPr sz="1600" b="1">
+                <a:solidFill>
+                  <a:srgbClr val="1B2A4A"/>
+                </a:solidFill>
+              </a:defRPr>
+            </a:pPr>
+            <a:r>
+              <a:t>No structural tests on source code</a:t>
+            </a:r>
+          </a:p>
+        </p:txBody>
+      </p:sp>
+      <p:sp>
+        <p:nvSpPr>
+          <p:cNvPr id="29" name="gen_desc_29"/>
+          <p:cNvSpPr txBox="1"/>
+          <p:nvPr/>
+        </p:nvSpPr>
+        <p:spPr>
+          <a:xfrm>
+            <a:off x="5120640" y="5431536"/>
+            <a:ext cx="6400800" cy="502920"/>
+          </a:xfrm>
+          <a:prstGeom prst="rect">
+            <a:avLst/>
+          </a:prstGeom>
+          <a:noFill/>
+        </p:spPr>
+        <p:txBody>
+          <a:bodyPr wrap="square">
+            <a:spAutoFit/>
+          </a:bodyPr>
+          <a:lstStyle/>
+          <a:p>
+            <a:pPr>
+              <a:lnSpc>
+                <a:spcPts val="1900"/>
+              </a:lnSpc>
+              <a:defRPr sz="1400">
+                <a:solidFill>
+                  <a:srgbClr val="374151"/>
+                </a:solidFill>
+              </a:defRPr>
+            </a:pPr>
+            <a:r>
+              <a:t>Don’t assert a function or import exists — such tests break on refactors and give false coverage</a:t>
+            </a:r>
+          </a:p>
+        </p:txBody>
+      </p:sp>
+      <p:sp>
+        <p:nvSpPr>
+          <p:cNvPr id="30" name="gen_oval_30"/>
+          <p:cNvSpPr/>
+          <p:nvPr/>
+        </p:nvSpPr>
+        <p:spPr>
+          <a:xfrm>
+            <a:off x="731520" y="5961888"/>
+            <a:ext cx="164592" cy="164592"/>
+          </a:xfrm>
+          <a:prstGeom prst="ellipse">
+            <a:avLst/>
+          </a:prstGeom>
+          <a:solidFill>
+            <a:srgbClr val="7C3AED"/>
+          </a:solidFill>
+          <a:ln>
+            <a:noFill/>
+          </a:ln>
+        </p:spPr>
+        <p:style>
+          <a:lnRef idx="1">
+            <a:schemeClr val="accent1"/>
+          </a:lnRef>
+          <a:fillRef idx="3">
+            <a:schemeClr val="accent1"/>
+          </a:fillRef>
+          <a:effectRef idx="2">
+            <a:schemeClr val="accent1"/>
+          </a:effectRef>
+          <a:fontRef idx="minor">
+            <a:schemeClr val="lt1"/>
+          </a:fontRef>
+        </p:style>
+        <p:txBody>
+          <a:bodyPr rtlCol="0" anchor="ctr"/>
+          <a:lstStyle/>
+          <a:p>
+            <a:pPr algn="ctr"/>
+            <a:endParaRPr/>
+          </a:p>
+        </p:txBody>
+      </p:sp>
+      <p:sp>
+        <p:nvSpPr>
+          <p:cNvPr id="31" name="gen_title_31"/>
+          <p:cNvSpPr txBox="1"/>
+          <p:nvPr/>
+        </p:nvSpPr>
+        <p:spPr>
+          <a:xfrm>
+            <a:off x="1097280" y="5907024"/>
+            <a:ext cx="3840480" cy="502920"/>
+          </a:xfrm>
+          <a:prstGeom prst="rect">
+            <a:avLst/>
+          </a:prstGeom>
+          <a:noFill/>
+        </p:spPr>
+        <p:txBody>
+          <a:bodyPr wrap="square">
+            <a:spAutoFit/>
+          </a:bodyPr>
+          <a:lstStyle/>
+          <a:p>
+            <a:pPr>
+              <a:defRPr sz="1600" b="1">
+                <a:solidFill>
+                  <a:srgbClr val="1B2A4A"/>
+                </a:solidFill>
+              </a:defRPr>
+            </a:pPr>
+            <a:r>
+              <a:t>Parallelize tests when &gt; 100  (CRITICAL)</a:t>
+            </a:r>
+          </a:p>
+        </p:txBody>
+      </p:sp>
+      <p:sp>
+        <p:nvSpPr>
+          <p:cNvPr id="32" name="gen_desc_32"/>
+          <p:cNvSpPr txBox="1"/>
+          <p:nvPr/>
+        </p:nvSpPr>
+        <p:spPr>
+          <a:xfrm>
+            <a:off x="5120640" y="5907024"/>
+            <a:ext cx="6400800" cy="502920"/>
+          </a:xfrm>
+          <a:prstGeom prst="rect">
+            <a:avLst/>
+          </a:prstGeom>
+          <a:noFill/>
+        </p:spPr>
+        <p:txBody>
+          <a:bodyPr wrap="square">
+            <a:spAutoFit/>
+          </a:bodyPr>
+          <a:lstStyle/>
+          <a:p>
+            <a:pPr>
+              <a:lnSpc>
+                <a:spcPts val="1900"/>
+              </a:lnSpc>
+              <a:defRPr sz="1400">
+                <a:solidFill>
+                  <a:srgbClr val="374151"/>
+                </a:solidFill>
+              </a:defRPr>
+            </a:pPr>
+            <a:r>
+              <a:t>Count first; split into (cores − 2) shards via run_parallel — amortizes orchestration overhead</a:t>
             </a:r>
           </a:p>
         </p:txBody>

</xml_diff>